<commit_message>
Slides: sd-01-030 lines at ten words or fewer, PPTX re-exported
Co-Authored-By: Claude Opus 5.5 <noreply@anthropic.com>
Claude-Session: https://claude.ai/code/session_01PmqNRWe4NoiAuhPfHYj9Qq
</commit_message>
<xml_diff>
--- a/system-design-101/vi/lessons/sd-01-030/slides/sd-01-030.pptx
+++ b/system-design-101/vi/lessons/sd-01-030/slides/sd-01-030.pptx
@@ -3180,7 +3180,18 @@
                 <a:ea typeface="Be Vietnam Pro" pitchFamily="34" charset="-122"/>
                 <a:cs typeface="Be Vietnam Pro" pitchFamily="34" charset="-120"/>
               </a:rPr>
-              <a:t> của dịch vụ</a:t>
+              <a:t> dịch</a:t>
+            </a:r>
+            <a:r>
+              <a:rPr lang="en-US" sz="2250" dirty="0" spc="1" kern="0">
+                <a:solidFill>
+                  <a:srgbClr val="F3EEE3"/>
+                </a:solidFill>
+                <a:latin typeface="Be Vietnam Pro" pitchFamily="34" charset="0"/>
+                <a:ea typeface="Be Vietnam Pro" pitchFamily="34" charset="-122"/>
+                <a:cs typeface="Be Vietnam Pro" pitchFamily="34" charset="-120"/>
+              </a:rPr>
+              <a:t> vụ</a:t>
             </a:r>
             <a:endParaRPr lang="en-US" sz="2250" dirty="0"/>
           </a:p>
@@ -3369,7 +3380,7 @@
               <a:t> vệ</a:t>
             </a:r>
             <a:r>
-              <a:rPr lang="en-US" sz="2250" dirty="0" spc="5" kern="0">
+              <a:rPr lang="en-US" sz="2250" dirty="0" spc="7" kern="0">
                 <a:solidFill>
                   <a:srgbClr val="F3EEE3"/>
                 </a:solidFill>
@@ -3377,10 +3388,10 @@
                 <a:ea typeface="Be Vietnam Pro" pitchFamily="34" charset="-122"/>
                 <a:cs typeface="Be Vietnam Pro" pitchFamily="34" charset="-120"/>
               </a:rPr>
-              <a:t> dữ</a:t>
-            </a:r>
-            <a:r>
-              <a:rPr lang="en-US" sz="2250" dirty="0" spc="-2" kern="0">
+              <a:t> đường</a:t>
+            </a:r>
+            <a:r>
+              <a:rPr lang="en-US" sz="2250" dirty="0" spc="-12" kern="0">
                 <a:solidFill>
                   <a:srgbClr val="F3EEE3"/>
                 </a:solidFill>
@@ -3388,7 +3399,29 @@
                 <a:ea typeface="Be Vietnam Pro" pitchFamily="34" charset="-122"/>
                 <a:cs typeface="Be Vietnam Pro" pitchFamily="34" charset="-120"/>
               </a:rPr>
-              <a:t> liệu</a:t>
+              <a:t> truyền</a:t>
+            </a:r>
+            <a:r>
+              <a:rPr lang="en-US" sz="2250" dirty="0" spc="-1" kern="0">
+                <a:solidFill>
+                  <a:srgbClr val="F3EEE3"/>
+                </a:solidFill>
+                <a:latin typeface="Be Vietnam Pro" pitchFamily="34" charset="0"/>
+                <a:ea typeface="Be Vietnam Pro" pitchFamily="34" charset="-122"/>
+                <a:cs typeface="Be Vietnam Pro" pitchFamily="34" charset="-120"/>
+              </a:rPr>
+              <a:t> khi</a:t>
+            </a:r>
+            <a:r>
+              <a:rPr lang="en-US" sz="2250" dirty="0" spc="0" kern="0">
+                <a:solidFill>
+                  <a:srgbClr val="F3EEE3"/>
+                </a:solidFill>
+                <a:latin typeface="Be Vietnam Pro" pitchFamily="34" charset="0"/>
+                <a:ea typeface="Be Vietnam Pro" pitchFamily="34" charset="-122"/>
+                <a:cs typeface="Be Vietnam Pro" pitchFamily="34" charset="-120"/>
+              </a:rPr>
+              <a:t> cấu hình,</a:t>
             </a:r>
             <a:r>
               <a:rPr lang="en-US" sz="2250" dirty="0" spc="-18" kern="0">
@@ -3399,62 +3432,7 @@
                 <a:ea typeface="Be Vietnam Pro" pitchFamily="34" charset="-122"/>
                 <a:cs typeface="Be Vietnam Pro" pitchFamily="34" charset="-120"/>
               </a:rPr>
-              <a:t> trên</a:t>
-            </a:r>
-            <a:r>
-              <a:rPr lang="en-US" sz="2250" dirty="0" spc="6" kern="0">
-                <a:solidFill>
-                  <a:srgbClr val="F3EEE3"/>
-                </a:solidFill>
-                <a:latin typeface="Be Vietnam Pro" pitchFamily="34" charset="0"/>
-                <a:ea typeface="Be Vietnam Pro" pitchFamily="34" charset="-122"/>
-                <a:cs typeface="Be Vietnam Pro" pitchFamily="34" charset="-120"/>
-              </a:rPr>
-              <a:t> đường</a:t>
-            </a:r>
-            <a:r>
-              <a:rPr lang="en-US" sz="2250" dirty="0" spc="-12" kern="0">
-                <a:solidFill>
-                  <a:srgbClr val="F3EEE3"/>
-                </a:solidFill>
-                <a:latin typeface="Be Vietnam Pro" pitchFamily="34" charset="0"/>
-                <a:ea typeface="Be Vietnam Pro" pitchFamily="34" charset="-122"/>
-                <a:cs typeface="Be Vietnam Pro" pitchFamily="34" charset="-120"/>
-              </a:rPr>
-              <a:t> truyền</a:t>
-            </a:r>
-            <a:r>
-              <a:rPr lang="en-US" sz="2250" dirty="0" spc="0" kern="0">
-                <a:solidFill>
-                  <a:srgbClr val="F3EEE3"/>
-                </a:solidFill>
-                <a:latin typeface="Be Vietnam Pro" pitchFamily="34" charset="0"/>
-                <a:ea typeface="Be Vietnam Pro" pitchFamily="34" charset="-122"/>
-                <a:cs typeface="Be Vietnam Pro" pitchFamily="34" charset="-120"/>
-              </a:rPr>
-              <a:t> khi cấu</a:t>
-            </a:r>
-            <a:r>
-              <a:rPr lang="en-US" sz="2250" dirty="0" spc="1" kern="0">
-                <a:solidFill>
-                  <a:srgbClr val="F3EEE3"/>
-                </a:solidFill>
-                <a:latin typeface="Be Vietnam Pro" pitchFamily="34" charset="0"/>
-                <a:ea typeface="Be Vietnam Pro" pitchFamily="34" charset="-122"/>
-                <a:cs typeface="Be Vietnam Pro" pitchFamily="34" charset="-120"/>
-              </a:rPr>
-              <a:t> hình</a:t>
-            </a:r>
-            <a:r>
-              <a:rPr lang="en-US" sz="2250" dirty="0" spc="-17" kern="0">
-                <a:solidFill>
-                  <a:srgbClr val="F3EEE3"/>
-                </a:solidFill>
-                <a:latin typeface="Be Vietnam Pro" pitchFamily="34" charset="0"/>
-                <a:ea typeface="Be Vietnam Pro" pitchFamily="34" charset="-122"/>
-                <a:cs typeface="Be Vietnam Pro" pitchFamily="34" charset="-120"/>
-              </a:rPr>
-              <a:t> và xác</a:t>
+              <a:t> xác</a:t>
             </a:r>
             <a:r>
               <a:rPr lang="en-US" sz="2250" dirty="0" spc="-1" kern="0">
@@ -7882,18 +7860,7 @@
               <a:t> xem</a:t>
             </a:r>
             <a:r>
-              <a:rPr lang="en-US" sz="2250" dirty="0" spc="10" kern="0">
-                <a:solidFill>
-                  <a:srgbClr val="FFB4A3"/>
-                </a:solidFill>
-                <a:latin typeface="Be Vietnam Pro SemiBold" pitchFamily="34" charset="0"/>
-                <a:ea typeface="Be Vietnam Pro SemiBold" pitchFamily="34" charset="-122"/>
-                <a:cs typeface="Be Vietnam Pro SemiBold" pitchFamily="34" charset="-120"/>
-              </a:rPr>
-              <a:t> được</a:t>
-            </a:r>
-            <a:r>
-              <a:rPr lang="en-US" sz="2250" dirty="0" spc="-2" kern="0">
+              <a:rPr lang="en-US" sz="2250" dirty="0" spc="-1" kern="0">
                 <a:solidFill>
                   <a:srgbClr val="FFB4A3"/>
                 </a:solidFill>
@@ -9165,10 +9132,10 @@
                 <a:ea typeface="Be Vietnam Pro" pitchFamily="34" charset="-122"/>
                 <a:cs typeface="Be Vietnam Pro" pitchFamily="34" charset="-120"/>
               </a:rPr>
-              <a:t>Mã hồ</a:t>
-            </a:r>
-            <a:r>
-              <a:rPr lang="en-US" sz="2400" dirty="0" spc="-8" kern="0">
+              <a:t>Mã</a:t>
+            </a:r>
+            <a:r>
+              <a:rPr lang="en-US" sz="2400" dirty="0" spc="3" kern="0">
                 <a:solidFill>
                   <a:srgbClr val="3B3A37"/>
                 </a:solidFill>
@@ -9176,10 +9143,10 @@
                 <a:ea typeface="Be Vietnam Pro" pitchFamily="34" charset="-122"/>
                 <a:cs typeface="Be Vietnam Pro" pitchFamily="34" charset="-120"/>
               </a:rPr>
-              <a:t> sơ</a:t>
-            </a:r>
-            <a:r>
-              <a:rPr lang="en-US" sz="2400" dirty="0" spc="3" kern="0">
+              <a:t> đúng</a:t>
+            </a:r>
+            <a:r>
+              <a:rPr lang="en-US" sz="2400" dirty="0" spc="-2" kern="0">
                 <a:solidFill>
                   <a:srgbClr val="3B3A37"/>
                 </a:solidFill>
@@ -9187,10 +9154,10 @@
                 <a:ea typeface="Be Vietnam Pro" pitchFamily="34" charset="-122"/>
                 <a:cs typeface="Be Vietnam Pro" pitchFamily="34" charset="-120"/>
               </a:rPr>
-              <a:t> đúng</a:t>
-            </a:r>
-            <a:r>
-              <a:rPr lang="en-US" sz="2400" dirty="0" spc="-2" kern="0">
+              <a:t> kiểu</a:t>
+            </a:r>
+            <a:r>
+              <a:rPr lang="en-US" sz="2400" dirty="0" spc="-12" kern="0">
                 <a:solidFill>
                   <a:srgbClr val="3B3A37"/>
                 </a:solidFill>
@@ -9198,10 +9165,10 @@
                 <a:ea typeface="Be Vietnam Pro" pitchFamily="34" charset="-122"/>
                 <a:cs typeface="Be Vietnam Pro" pitchFamily="34" charset="-120"/>
               </a:rPr>
-              <a:t> kiểu</a:t>
-            </a:r>
-            <a:r>
-              <a:rPr lang="en-US" sz="2400" dirty="0" spc="-12" kern="0">
+              <a:t> vẫn</a:t>
+            </a:r>
+            <a:r>
+              <a:rPr lang="en-US" sz="2400" dirty="0" spc="0" kern="0">
                 <a:solidFill>
                   <a:srgbClr val="3B3A37"/>
                 </a:solidFill>
@@ -9209,10 +9176,10 @@
                 <a:ea typeface="Be Vietnam Pro" pitchFamily="34" charset="-122"/>
                 <a:cs typeface="Be Vietnam Pro" pitchFamily="34" charset="-120"/>
               </a:rPr>
-              <a:t> vẫn</a:t>
-            </a:r>
-            <a:r>
-              <a:rPr lang="en-US" sz="2400" dirty="0" spc="0" kern="0">
+              <a:t> có</a:t>
+            </a:r>
+            <a:r>
+              <a:rPr lang="en-US" sz="2400" dirty="0" spc="1" kern="0">
                 <a:solidFill>
                   <a:srgbClr val="3B3A37"/>
                 </a:solidFill>
@@ -9220,10 +9187,10 @@
                 <a:ea typeface="Be Vietnam Pro" pitchFamily="34" charset="-122"/>
                 <a:cs typeface="Be Vietnam Pro" pitchFamily="34" charset="-120"/>
               </a:rPr>
-              <a:t> có</a:t>
-            </a:r>
-            <a:r>
-              <a:rPr lang="en-US" sz="2400" dirty="0" spc="1" kern="0">
+              <a:t> thể</a:t>
+            </a:r>
+            <a:r>
+              <a:rPr lang="en-US" sz="2400" dirty="0" spc="-3" kern="0">
                 <a:solidFill>
                   <a:srgbClr val="3B3A37"/>
                 </a:solidFill>
@@ -9231,54 +9198,10 @@
                 <a:ea typeface="Be Vietnam Pro" pitchFamily="34" charset="-122"/>
                 <a:cs typeface="Be Vietnam Pro" pitchFamily="34" charset="-120"/>
               </a:rPr>
-              <a:t> thể</a:t>
-            </a:r>
-            <a:r>
-              <a:rPr lang="en-US" sz="2400" dirty="0" spc="2" kern="0">
-                <a:solidFill>
-                  <a:srgbClr val="3B3A37"/>
-                </a:solidFill>
-                <a:latin typeface="Be Vietnam Pro" pitchFamily="34" charset="0"/>
-                <a:ea typeface="Be Vietnam Pro" pitchFamily="34" charset="-122"/>
-                <a:cs typeface="Be Vietnam Pro" pitchFamily="34" charset="-120"/>
-              </a:rPr>
-              <a:t> là</a:t>
-            </a:r>
-            <a:r>
-              <a:rPr lang="en-US" sz="2400" dirty="0" spc="1" kern="0">
-                <a:solidFill>
-                  <a:srgbClr val="3B3A37"/>
-                </a:solidFill>
-                <a:latin typeface="Be Vietnam Pro" pitchFamily="34" charset="0"/>
-                <a:ea typeface="Be Vietnam Pro" pitchFamily="34" charset="-122"/>
-                <a:cs typeface="Be Vietnam Pro" pitchFamily="34" charset="-120"/>
-              </a:rPr>
-              <a:t> hồ</a:t>
-            </a:r>
-            <a:r>
-              <a:rPr lang="en-US" sz="2400" dirty="0" spc="-8" kern="0">
-                <a:solidFill>
-                  <a:srgbClr val="3B3A37"/>
-                </a:solidFill>
-                <a:latin typeface="Be Vietnam Pro" pitchFamily="34" charset="0"/>
-                <a:ea typeface="Be Vietnam Pro" pitchFamily="34" charset="-122"/>
-                <a:cs typeface="Be Vietnam Pro" pitchFamily="34" charset="-120"/>
-              </a:rPr>
-              <a:t> sơ</a:t>
-            </a:r>
-            <a:r>
-              <a:rPr lang="en-US" sz="2400" dirty="0" spc="2" kern="0">
-                <a:solidFill>
-                  <a:srgbClr val="3B3A37"/>
-                </a:solidFill>
-                <a:latin typeface="Be Vietnam Pro" pitchFamily="34" charset="0"/>
-                <a:ea typeface="Be Vietnam Pro" pitchFamily="34" charset="-122"/>
-                <a:cs typeface="Be Vietnam Pro" pitchFamily="34" charset="-120"/>
-              </a:rPr>
-              <a:t> của</a:t>
-            </a:r>
-            <a:r>
-              <a:rPr lang="en-US" sz="2400" dirty="0" spc="6" kern="0">
+              <a:t> thuộc</a:t>
+            </a:r>
+            <a:r>
+              <a:rPr lang="en-US" sz="2400" dirty="0" spc="7" kern="0">
                 <a:solidFill>
                   <a:srgbClr val="3B3A37"/>
                 </a:solidFill>
@@ -10387,7 +10310,7 @@
               <a:buNone/>
             </a:pPr>
             <a:r>
-              <a:rPr lang="en-US" sz="2700" b="1" dirty="0" spc="-16" kern="0">
+              <a:rPr lang="en-US" sz="2700" b="1" dirty="0" spc="0" kern="0">
                 <a:solidFill>
                   <a:srgbClr val="FFB454"/>
                 </a:solidFill>
@@ -10395,7 +10318,7 @@
                 <a:ea typeface="Be Vietnam Pro" pitchFamily="34" charset="-122"/>
                 <a:cs typeface="Be Vietnam Pro" pitchFamily="34" charset="-120"/>
               </a:rPr>
-              <a:t>Một</a:t>
+              <a:t>Ít</a:t>
             </a:r>
             <a:r>
               <a:rPr lang="en-US" sz="2700" b="1" dirty="0" spc="-21" kern="0">
@@ -10420,7 +10343,7 @@
               <a:t> cầu</a:t>
             </a:r>
             <a:r>
-              <a:rPr lang="en-US" sz="2700" b="1" dirty="0" spc="-2" kern="0">
+              <a:rPr lang="en-US" sz="2700" b="1" dirty="0" spc="-14" kern="0">
                 <a:solidFill>
                   <a:srgbClr val="FFB454"/>
                 </a:solidFill>
@@ -10428,10 +10351,10 @@
                 <a:ea typeface="Be Vietnam Pro" pitchFamily="34" charset="-122"/>
                 <a:cs typeface="Be Vietnam Pro" pitchFamily="34" charset="-120"/>
               </a:rPr>
-              <a:t> ít</a:t>
-            </a:r>
-            <a:r>
-              <a:rPr lang="en-US" sz="2700" b="1" dirty="0" spc="-22" kern="0">
+              <a:t> vẫn</a:t>
+            </a:r>
+            <a:r>
+              <a:rPr lang="en-US" sz="2700" b="1" dirty="0" spc="-7" kern="0">
                 <a:solidFill>
                   <a:srgbClr val="FFB454"/>
                 </a:solidFill>
@@ -10439,7 +10362,7 @@
                 <a:ea typeface="Be Vietnam Pro" pitchFamily="34" charset="-122"/>
                 <a:cs typeface="Be Vietnam Pro" pitchFamily="34" charset="-120"/>
               </a:rPr>
-              <a:t> về</a:t>
+              <a:t> có</a:t>
             </a:r>
             <a:r>
               <a:rPr lang="en-US" sz="2700" b="1" dirty="0" spc="-4" kern="0">
@@ -10450,10 +10373,10 @@
                 <a:ea typeface="Be Vietnam Pro" pitchFamily="34" charset="-122"/>
                 <a:cs typeface="Be Vietnam Pro" pitchFamily="34" charset="-120"/>
               </a:rPr>
-              <a:t> số</a:t>
-            </a:r>
-            <a:r>
-              <a:rPr lang="en-US" sz="2700" b="1" dirty="0" spc="8" kern="0">
+              <a:t> thể</a:t>
+            </a:r>
+            <a:r>
+              <a:rPr lang="en-US" sz="2700" b="1" dirty="0" spc="-23" kern="0">
                 <a:solidFill>
                   <a:srgbClr val="FFB454"/>
                 </a:solidFill>
@@ -10461,54 +10384,10 @@
                 <a:ea typeface="Be Vietnam Pro" pitchFamily="34" charset="-122"/>
                 <a:cs typeface="Be Vietnam Pro" pitchFamily="34" charset="-120"/>
               </a:rPr>
-              <a:t> lượng</a:t>
-            </a:r>
-            <a:r>
-              <a:rPr lang="en-US" sz="2700" b="1" dirty="0" spc="-15" kern="0">
-                <a:solidFill>
-                  <a:srgbClr val="FFB454"/>
-                </a:solidFill>
-                <a:latin typeface="Be Vietnam Pro" pitchFamily="34" charset="0"/>
-                <a:ea typeface="Be Vietnam Pro" pitchFamily="34" charset="-122"/>
-                <a:cs typeface="Be Vietnam Pro" pitchFamily="34" charset="-120"/>
-              </a:rPr>
-              <a:t> vẫn</a:t>
-            </a:r>
-            <a:r>
-              <a:rPr lang="en-US" sz="2700" b="1" dirty="0" spc="-7" kern="0">
-                <a:solidFill>
-                  <a:srgbClr val="FFB454"/>
-                </a:solidFill>
-                <a:latin typeface="Be Vietnam Pro" pitchFamily="34" charset="0"/>
-                <a:ea typeface="Be Vietnam Pro" pitchFamily="34" charset="-122"/>
-                <a:cs typeface="Be Vietnam Pro" pitchFamily="34" charset="-120"/>
-              </a:rPr>
-              <a:t> có</a:t>
-            </a:r>
-            <a:r>
-              <a:rPr lang="en-US" sz="2700" b="1" dirty="0" spc="-4" kern="0">
-                <a:solidFill>
-                  <a:srgbClr val="FFB454"/>
-                </a:solidFill>
-                <a:latin typeface="Be Vietnam Pro" pitchFamily="34" charset="0"/>
-                <a:ea typeface="Be Vietnam Pro" pitchFamily="34" charset="-122"/>
-                <a:cs typeface="Be Vietnam Pro" pitchFamily="34" charset="-120"/>
-              </a:rPr>
-              <a:t> thể</a:t>
-            </a:r>
-            <a:r>
-              <a:rPr lang="en-US" sz="2700" b="1" dirty="0" spc="-23" kern="0">
-                <a:solidFill>
-                  <a:srgbClr val="FFB454"/>
-                </a:solidFill>
-                <a:latin typeface="Be Vietnam Pro" pitchFamily="34" charset="0"/>
-                <a:ea typeface="Be Vietnam Pro" pitchFamily="34" charset="-122"/>
-                <a:cs typeface="Be Vietnam Pro" pitchFamily="34" charset="-120"/>
-              </a:rPr>
               <a:t> rất</a:t>
             </a:r>
             <a:r>
-              <a:rPr lang="en-US" sz="2700" b="1" dirty="0" spc="-10" kern="0">
+              <a:rPr lang="en-US" sz="2700" b="1" dirty="0" spc="-11" kern="0">
                 <a:solidFill>
                   <a:srgbClr val="FFB454"/>
                 </a:solidFill>
@@ -12027,28 +11906,6 @@
               <a:t> tự</a:t>
             </a:r>
             <a:r>
-              <a:rPr lang="en-US" sz="2250" dirty="0" spc="2" kern="0">
-                <a:solidFill>
-                  <a:srgbClr val="C9CDD8"/>
-                </a:solidFill>
-                <a:latin typeface="Be Vietnam Pro" pitchFamily="34" charset="0"/>
-                <a:ea typeface="Be Vietnam Pro" pitchFamily="34" charset="-122"/>
-                <a:cs typeface="Be Vietnam Pro" pitchFamily="34" charset="-120"/>
-              </a:rPr>
-              <a:t> xử</a:t>
-            </a:r>
-            <a:r>
-              <a:rPr lang="en-US" sz="2250" dirty="0" spc="1" kern="0">
-                <a:solidFill>
-                  <a:srgbClr val="C9CDD8"/>
-                </a:solidFill>
-                <a:latin typeface="Be Vietnam Pro" pitchFamily="34" charset="0"/>
-                <a:ea typeface="Be Vietnam Pro" pitchFamily="34" charset="-122"/>
-                <a:cs typeface="Be Vietnam Pro" pitchFamily="34" charset="-120"/>
-              </a:rPr>
-              <a:t> lý</a:t>
-            </a:r>
-            <a:r>
               <a:rPr lang="en-US" sz="2250" dirty="0" spc="-13" kern="0">
                 <a:solidFill>
                   <a:srgbClr val="C9CDD8"/>
@@ -12641,7 +12498,7 @@
               <a:buNone/>
             </a:pPr>
             <a:r>
-              <a:rPr lang="en-US" sz="2850" dirty="0" spc="8" kern="0">
+              <a:rPr lang="en-US" sz="2850" dirty="0" spc="-2" kern="0">
                 <a:solidFill>
                   <a:srgbClr val="3B3A37"/>
                 </a:solidFill>
@@ -12649,10 +12506,10 @@
                 <a:ea typeface="Be Vietnam Pro" pitchFamily="34" charset="-122"/>
                 <a:cs typeface="Be Vietnam Pro" pitchFamily="34" charset="-120"/>
               </a:rPr>
-              <a:t>Người</a:t>
-            </a:r>
-            <a:r>
-              <a:rPr lang="en-US" sz="2850" dirty="0" spc="20" kern="0">
+              <a:t>Đổi</a:t>
+            </a:r>
+            <a:r>
+              <a:rPr lang="en-US" sz="2850" dirty="0" spc="0" kern="0">
                 <a:solidFill>
                   <a:srgbClr val="3B3A37"/>
                 </a:solidFill>
@@ -12660,10 +12517,10 @@
                 <a:ea typeface="Be Vietnam Pro" pitchFamily="34" charset="-122"/>
                 <a:cs typeface="Be Vietnam Pro" pitchFamily="34" charset="-120"/>
               </a:rPr>
-              <a:t> đã</a:t>
-            </a:r>
-            <a:r>
-              <a:rPr lang="en-US" sz="2850" dirty="0" spc="10" kern="0">
+              <a:t> mã,</a:t>
+            </a:r>
+            <a:r>
+              <a:rPr lang="en-US" sz="2850" dirty="0" spc="-21" kern="0">
                 <a:solidFill>
                   <a:srgbClr val="3B3A37"/>
                 </a:solidFill>
@@ -12671,7 +12528,40 @@
                 <a:ea typeface="Be Vietnam Pro" pitchFamily="34" charset="-122"/>
                 <a:cs typeface="Be Vietnam Pro" pitchFamily="34" charset="-120"/>
               </a:rPr>
-              <a:t> đăng</a:t>
+              <a:t> xem</a:t>
+            </a:r>
+            <a:r>
+              <a:rPr lang="en-US" sz="2850" dirty="0" spc="0" kern="0">
+                <a:solidFill>
+                  <a:srgbClr val="3B3A37"/>
+                </a:solidFill>
+                <a:latin typeface="Be Vietnam Pro" pitchFamily="34" charset="0"/>
+                <a:ea typeface="Be Vietnam Pro" pitchFamily="34" charset="-122"/>
+                <a:cs typeface="Be Vietnam Pro" pitchFamily="34" charset="-120"/>
+              </a:rPr>
+              <a:t> hồ</a:t>
+            </a:r>
+            <a:r>
+              <a:rPr lang="en-US" sz="2850" dirty="0" spc="-7" kern="0">
+                <a:solidFill>
+                  <a:srgbClr val="3B3A37"/>
+                </a:solidFill>
+                <a:latin typeface="Be Vietnam Pro" pitchFamily="34" charset="0"/>
+                <a:ea typeface="Be Vietnam Pro" pitchFamily="34" charset="-122"/>
+                <a:cs typeface="Be Vietnam Pro" pitchFamily="34" charset="-120"/>
+              </a:rPr>
+              <a:t> sơ</a:t>
+            </a:r>
+            <a:r>
+              <a:rPr lang="en-US" sz="2850" dirty="0" spc="7" kern="0">
+                <a:solidFill>
+                  <a:srgbClr val="3B3A37"/>
+                </a:solidFill>
+                <a:latin typeface="Be Vietnam Pro" pitchFamily="34" charset="0"/>
+                <a:ea typeface="Be Vietnam Pro" pitchFamily="34" charset="-122"/>
+                <a:cs typeface="Be Vietnam Pro" pitchFamily="34" charset="-120"/>
+              </a:rPr>
+              <a:t> người</a:t>
             </a:r>
             <a:r>
               <a:rPr lang="en-US" sz="2850" dirty="0" spc="-1" kern="0">
@@ -12682,10 +12572,10 @@
                 <a:ea typeface="Be Vietnam Pro" pitchFamily="34" charset="-122"/>
                 <a:cs typeface="Be Vietnam Pro" pitchFamily="34" charset="-120"/>
               </a:rPr>
-              <a:t> nhập</a:t>
-            </a:r>
-            <a:r>
-              <a:rPr lang="en-US" sz="2850" dirty="0" spc="12" kern="0">
+              <a:t> khác:</a:t>
+            </a:r>
+            <a:r>
+              <a:rPr lang="en-US" sz="2850" dirty="0" spc="0" kern="0">
                 <a:solidFill>
                   <a:srgbClr val="3B3A37"/>
                 </a:solidFill>
@@ -12693,7 +12583,18 @@
                 <a:ea typeface="Be Vietnam Pro" pitchFamily="34" charset="-122"/>
                 <a:cs typeface="Be Vietnam Pro" pitchFamily="34" charset="-120"/>
               </a:rPr>
-              <a:t> sửa</a:t>
+              <a:t> lớp</a:t>
+            </a:r>
+            <a:r>
+              <a:rPr lang="en-US" sz="2850" dirty="0" spc="1" kern="0">
+                <a:solidFill>
+                  <a:srgbClr val="3B3A37"/>
+                </a:solidFill>
+                <a:latin typeface="Be Vietnam Pro" pitchFamily="34" charset="0"/>
+                <a:ea typeface="Be Vietnam Pro" pitchFamily="34" charset="-122"/>
+                <a:cs typeface="Be Vietnam Pro" pitchFamily="34" charset="-120"/>
+              </a:rPr>
+              <a:t> nào</a:t>
             </a:r>
             <a:r>
               <a:rPr lang="en-US" sz="2850" dirty="0" spc="-1" kern="0">
@@ -12704,161 +12605,7 @@
                 <a:ea typeface="Be Vietnam Pro" pitchFamily="34" charset="-122"/>
                 <a:cs typeface="Be Vietnam Pro" pitchFamily="34" charset="-120"/>
               </a:rPr>
-              <a:t> mã</a:t>
-            </a:r>
-            <a:r>
-              <a:rPr lang="en-US" sz="2850" dirty="0" spc="0" kern="0">
-                <a:solidFill>
-                  <a:srgbClr val="3B3A37"/>
-                </a:solidFill>
-                <a:latin typeface="Be Vietnam Pro" pitchFamily="34" charset="0"/>
-                <a:ea typeface="Be Vietnam Pro" pitchFamily="34" charset="-122"/>
-                <a:cs typeface="Be Vietnam Pro" pitchFamily="34" charset="-120"/>
-              </a:rPr>
-              <a:t> hồ</a:t>
-            </a:r>
-            <a:r>
-              <a:rPr lang="en-US" sz="2850" dirty="0" spc="-6" kern="0">
-                <a:solidFill>
-                  <a:srgbClr val="3B3A37"/>
-                </a:solidFill>
-                <a:latin typeface="Be Vietnam Pro" pitchFamily="34" charset="0"/>
-                <a:ea typeface="Be Vietnam Pro" pitchFamily="34" charset="-122"/>
-                <a:cs typeface="Be Vietnam Pro" pitchFamily="34" charset="-120"/>
-              </a:rPr>
-              <a:t> sơ</a:t>
-            </a:r>
-            <a:r>
-              <a:rPr lang="en-US" sz="2850" dirty="0" spc="19" kern="0">
-                <a:solidFill>
-                  <a:srgbClr val="3B3A37"/>
-                </a:solidFill>
-                <a:latin typeface="Be Vietnam Pro" pitchFamily="34" charset="0"/>
-                <a:ea typeface="Be Vietnam Pro" pitchFamily="34" charset="-122"/>
-                <a:cs typeface="Be Vietnam Pro" pitchFamily="34" charset="-120"/>
-              </a:rPr>
-              <a:t> để</a:t>
-            </a:r>
-            <a:r>
-              <a:rPr lang="en-US" sz="2850" dirty="0" spc="-21" kern="0">
-                <a:solidFill>
-                  <a:srgbClr val="3B3A37"/>
-                </a:solidFill>
-                <a:latin typeface="Be Vietnam Pro" pitchFamily="34" charset="0"/>
-                <a:ea typeface="Be Vietnam Pro" pitchFamily="34" charset="-122"/>
-                <a:cs typeface="Be Vietnam Pro" pitchFamily="34" charset="-120"/>
-              </a:rPr>
-              <a:t> xem</a:t>
-            </a:r>
-            <a:r>
-              <a:rPr lang="en-US" sz="2850" dirty="0" spc="-1" kern="0">
-                <a:solidFill>
-                  <a:srgbClr val="3B3A37"/>
-                </a:solidFill>
-                <a:latin typeface="Be Vietnam Pro" pitchFamily="34" charset="0"/>
-                <a:ea typeface="Be Vietnam Pro" pitchFamily="34" charset="-122"/>
-                <a:cs typeface="Be Vietnam Pro" pitchFamily="34" charset="-120"/>
-              </a:rPr>
-              <a:t> thú</a:t>
-            </a:r>
-            <a:r>
-              <a:rPr lang="en-US" sz="2850" dirty="0" spc="22" kern="0">
-                <a:solidFill>
-                  <a:srgbClr val="3B3A37"/>
-                </a:solidFill>
-                <a:latin typeface="Be Vietnam Pro" pitchFamily="34" charset="0"/>
-                <a:ea typeface="Be Vietnam Pro" pitchFamily="34" charset="-122"/>
-                <a:cs typeface="Be Vietnam Pro" pitchFamily="34" charset="-120"/>
-              </a:rPr>
-              <a:t> cưng</a:t>
-            </a:r>
-            <a:r>
-              <a:rPr lang="en-US" sz="2850" dirty="0" spc="2" kern="0">
-                <a:solidFill>
-                  <a:srgbClr val="3B3A37"/>
-                </a:solidFill>
-                <a:latin typeface="Be Vietnam Pro" pitchFamily="34" charset="0"/>
-                <a:ea typeface="Be Vietnam Pro" pitchFamily="34" charset="-122"/>
-                <a:cs typeface="Be Vietnam Pro" pitchFamily="34" charset="-120"/>
-              </a:rPr>
-              <a:t> của</a:t>
-            </a:r>
-            <a:r>
-              <a:rPr lang="en-US" sz="2850" dirty="0" spc="-14" kern="0">
-                <a:solidFill>
-                  <a:srgbClr val="3B3A37"/>
-                </a:solidFill>
-                <a:latin typeface="Be Vietnam Pro" pitchFamily="34" charset="0"/>
-                <a:ea typeface="Be Vietnam Pro" pitchFamily="34" charset="-122"/>
-                <a:cs typeface="Be Vietnam Pro" pitchFamily="34" charset="-120"/>
-              </a:rPr>
-              <a:t> tài</a:t>
-            </a:r>
-            <a:r>
-              <a:rPr lang="en-US" sz="2850" dirty="0" spc="-3" kern="0">
-                <a:solidFill>
-                  <a:srgbClr val="3B3A37"/>
-                </a:solidFill>
-                <a:latin typeface="Be Vietnam Pro" pitchFamily="34" charset="0"/>
-                <a:ea typeface="Be Vietnam Pro" pitchFamily="34" charset="-122"/>
-                <a:cs typeface="Be Vietnam Pro" pitchFamily="34" charset="-120"/>
-              </a:rPr>
-              <a:t> khoản</a:t>
-            </a:r>
-            <a:r>
-              <a:rPr lang="en-US" sz="2850" dirty="0" spc="-1" kern="0">
-                <a:solidFill>
-                  <a:srgbClr val="3B3A37"/>
-                </a:solidFill>
-                <a:latin typeface="Be Vietnam Pro" pitchFamily="34" charset="0"/>
-                <a:ea typeface="Be Vietnam Pro" pitchFamily="34" charset="-122"/>
-                <a:cs typeface="Be Vietnam Pro" pitchFamily="34" charset="-120"/>
-              </a:rPr>
-              <a:t> khác.</a:t>
-            </a:r>
-            <a:r>
-              <a:rPr lang="en-US" sz="2850" dirty="0" spc="-28" kern="0">
-                <a:solidFill>
-                  <a:srgbClr val="3B3A37"/>
-                </a:solidFill>
-                <a:latin typeface="Be Vietnam Pro" pitchFamily="34" charset="0"/>
-                <a:ea typeface="Be Vietnam Pro" pitchFamily="34" charset="-122"/>
-                <a:cs typeface="Be Vietnam Pro" pitchFamily="34" charset="-120"/>
-              </a:rPr>
-              <a:t> Lớp</a:t>
-            </a:r>
-            <a:r>
-              <a:rPr lang="en-US" sz="2850" dirty="0" spc="1" kern="0">
-                <a:solidFill>
-                  <a:srgbClr val="3B3A37"/>
-                </a:solidFill>
-                <a:latin typeface="Be Vietnam Pro" pitchFamily="34" charset="0"/>
-                <a:ea typeface="Be Vietnam Pro" pitchFamily="34" charset="-122"/>
-                <a:cs typeface="Be Vietnam Pro" pitchFamily="34" charset="-120"/>
-              </a:rPr>
-              <a:t> nào</a:t>
-            </a:r>
-            <a:r>
-              <a:rPr lang="en-US" sz="2850" dirty="0" spc="-22" kern="0">
-                <a:solidFill>
-                  <a:srgbClr val="3B3A37"/>
-                </a:solidFill>
-                <a:latin typeface="Be Vietnam Pro" pitchFamily="34" charset="0"/>
-                <a:ea typeface="Be Vietnam Pro" pitchFamily="34" charset="-122"/>
-                <a:cs typeface="Be Vietnam Pro" pitchFamily="34" charset="-120"/>
-              </a:rPr>
-              <a:t> quyết</a:t>
-            </a:r>
-            <a:r>
-              <a:rPr lang="en-US" sz="2850" dirty="0" spc="18" kern="0">
-                <a:solidFill>
-                  <a:srgbClr val="3B3A37"/>
-                </a:solidFill>
-                <a:latin typeface="Be Vietnam Pro" pitchFamily="34" charset="0"/>
-                <a:ea typeface="Be Vietnam Pro" pitchFamily="34" charset="-122"/>
-                <a:cs typeface="Be Vietnam Pro" pitchFamily="34" charset="-120"/>
-              </a:rPr>
-              <a:t> định?</a:t>
+              <a:t> chặn?</a:t>
             </a:r>
             <a:endParaRPr lang="en-US" sz="2850" dirty="0"/>
           </a:p>
@@ -14221,7 +13968,7 @@
               <a:t> bắt</a:t>
             </a:r>
             <a:r>
-              <a:rPr lang="en-US" sz="2400" dirty="0" spc="-2" kern="0">
+              <a:rPr lang="en-US" sz="2400" dirty="0" spc="-3" kern="0">
                 <a:solidFill>
                   <a:srgbClr val="3B3A37"/>
                 </a:solidFill>
@@ -14229,10 +13976,10 @@
                 <a:ea typeface="Be Vietnam Pro" pitchFamily="34" charset="-122"/>
                 <a:cs typeface="Be Vietnam Pro" pitchFamily="34" charset="-120"/>
               </a:rPr>
-              <a:t> buộc,</a:t>
-            </a:r>
-            <a:r>
-              <a:rPr lang="en-US" sz="2400" dirty="0" spc="1" kern="0">
+              <a:t> buộc</a:t>
+            </a:r>
+            <a:r>
+              <a:rPr lang="en-US" sz="2400" dirty="0" spc="-8" kern="0">
                 <a:solidFill>
                   <a:srgbClr val="3B3A37"/>
                 </a:solidFill>
@@ -14240,7 +13987,18 @@
                 <a:ea typeface="Be Vietnam Pro" pitchFamily="34" charset="-122"/>
                 <a:cs typeface="Be Vietnam Pro" pitchFamily="34" charset="-120"/>
               </a:rPr>
-              <a:t> không phải danh</a:t>
+              <a:t> hay</a:t>
+            </a:r>
+            <a:r>
+              <a:rPr lang="en-US" sz="2400" dirty="0" spc="2" kern="0">
+                <a:solidFill>
+                  <a:srgbClr val="3B3A37"/>
+                </a:solidFill>
+                <a:latin typeface="Be Vietnam Pro" pitchFamily="34" charset="0"/>
+                <a:ea typeface="Be Vietnam Pro" pitchFamily="34" charset="-122"/>
+                <a:cs typeface="Be Vietnam Pro" pitchFamily="34" charset="-120"/>
+              </a:rPr>
+              <a:t> danh</a:t>
             </a:r>
             <a:r>
               <a:rPr lang="en-US" sz="2400" dirty="0" spc="-6" kern="0">
@@ -14252,17 +14010,6 @@
                 <a:cs typeface="Be Vietnam Pro" pitchFamily="34" charset="-120"/>
               </a:rPr>
               <a:t> sách</a:t>
-            </a:r>
-            <a:r>
-              <a:rPr lang="en-US" sz="2400" dirty="0" spc="5" kern="0">
-                <a:solidFill>
-                  <a:srgbClr val="3B3A37"/>
-                </a:solidFill>
-                <a:latin typeface="Be Vietnam Pro" pitchFamily="34" charset="0"/>
-                <a:ea typeface="Be Vietnam Pro" pitchFamily="34" charset="-122"/>
-                <a:cs typeface="Be Vietnam Pro" pitchFamily="34" charset="-120"/>
-              </a:rPr>
-              <a:t> đầy</a:t>
             </a:r>
             <a:r>
               <a:rPr lang="en-US" sz="2400" dirty="0" spc="3" kern="0">
@@ -14681,73 +14428,51 @@
               <a:t> tốn</a:t>
             </a:r>
             <a:r>
+              <a:rPr lang="en-US" sz="2400" dirty="0" spc="-21" kern="0">
+                <a:solidFill>
+                  <a:srgbClr val="3B3A37"/>
+                </a:solidFill>
+                <a:latin typeface="Be Vietnam Pro" pitchFamily="34" charset="0"/>
+                <a:ea typeface="Be Vietnam Pro" pitchFamily="34" charset="-122"/>
+                <a:cs typeface="Be Vietnam Pro" pitchFamily="34" charset="-120"/>
+              </a:rPr>
+              <a:t> kém,</a:t>
+            </a:r>
+            <a:r>
+              <a:rPr lang="en-US" sz="2400" dirty="0" spc="17" kern="0">
+                <a:solidFill>
+                  <a:srgbClr val="3B3A37"/>
+                </a:solidFill>
+                <a:latin typeface="Be Vietnam Pro" pitchFamily="34" charset="0"/>
+                <a:ea typeface="Be Vietnam Pro" pitchFamily="34" charset="-122"/>
+                <a:cs typeface="Be Vietnam Pro" pitchFamily="34" charset="-120"/>
+              </a:rPr>
+              <a:t> lưu</a:t>
+            </a:r>
+            <a:r>
+              <a:rPr lang="en-US" sz="2400" dirty="0" spc="7" kern="0">
+                <a:solidFill>
+                  <a:srgbClr val="3B3A37"/>
+                </a:solidFill>
+                <a:latin typeface="Be Vietnam Pro" pitchFamily="34" charset="0"/>
+                <a:ea typeface="Be Vietnam Pro" pitchFamily="34" charset="-122"/>
+                <a:cs typeface="Be Vietnam Pro" pitchFamily="34" charset="-120"/>
+              </a:rPr>
+              <a:t> lượng</a:t>
+            </a:r>
+            <a:r>
+              <a:rPr lang="en-US" sz="2400" dirty="0" spc="1" kern="0">
+                <a:solidFill>
+                  <a:srgbClr val="3B3A37"/>
+                </a:solidFill>
+                <a:latin typeface="Be Vietnam Pro" pitchFamily="34" charset="0"/>
+                <a:ea typeface="Be Vietnam Pro" pitchFamily="34" charset="-122"/>
+                <a:cs typeface="Be Vietnam Pro" pitchFamily="34" charset="-120"/>
+              </a:rPr>
+              <a:t> phân</a:t>
+            </a:r>
+            <a:r>
               <a:rPr lang="en-US" sz="2400" dirty="0" spc="-10" kern="0">
-                <a:solidFill>
-                  <a:srgbClr val="3B3A37"/>
-                </a:solidFill>
-                <a:latin typeface="Be Vietnam Pro" pitchFamily="34" charset="0"/>
-                <a:ea typeface="Be Vietnam Pro" pitchFamily="34" charset="-122"/>
-                <a:cs typeface="Be Vietnam Pro" pitchFamily="34" charset="-120"/>
-              </a:rPr>
-              <a:t> tài</a:t>
-            </a:r>
-            <a:r>
-              <a:rPr lang="en-US" sz="2400" dirty="0" spc="-12" kern="0">
-                <a:solidFill>
-                  <a:srgbClr val="3B3A37"/>
-                </a:solidFill>
-                <a:latin typeface="Be Vietnam Pro" pitchFamily="34" charset="0"/>
-                <a:ea typeface="Be Vietnam Pro" pitchFamily="34" charset="-122"/>
-                <a:cs typeface="Be Vietnam Pro" pitchFamily="34" charset="-120"/>
-              </a:rPr>
-              <a:t> nguyên</a:t>
-            </a:r>
-            <a:r>
-              <a:rPr lang="en-US" sz="2400" dirty="0" spc="-15" kern="0">
-                <a:solidFill>
-                  <a:srgbClr val="3B3A37"/>
-                </a:solidFill>
-                <a:latin typeface="Be Vietnam Pro" pitchFamily="34" charset="0"/>
-                <a:ea typeface="Be Vietnam Pro" pitchFamily="34" charset="-122"/>
-                <a:cs typeface="Be Vietnam Pro" pitchFamily="34" charset="-120"/>
-              </a:rPr>
-              <a:t> và</a:t>
-            </a:r>
-            <a:r>
-              <a:rPr lang="en-US" sz="2400" dirty="0" spc="16" kern="0">
-                <a:solidFill>
-                  <a:srgbClr val="3B3A37"/>
-                </a:solidFill>
-                <a:latin typeface="Be Vietnam Pro" pitchFamily="34" charset="0"/>
-                <a:ea typeface="Be Vietnam Pro" pitchFamily="34" charset="-122"/>
-                <a:cs typeface="Be Vietnam Pro" pitchFamily="34" charset="-120"/>
-              </a:rPr>
-              <a:t> lưu</a:t>
-            </a:r>
-            <a:r>
-              <a:rPr lang="en-US" sz="2400" dirty="0" spc="7" kern="0">
-                <a:solidFill>
-                  <a:srgbClr val="3B3A37"/>
-                </a:solidFill>
-                <a:latin typeface="Be Vietnam Pro" pitchFamily="34" charset="0"/>
-                <a:ea typeface="Be Vietnam Pro" pitchFamily="34" charset="-122"/>
-                <a:cs typeface="Be Vietnam Pro" pitchFamily="34" charset="-120"/>
-              </a:rPr>
-              <a:t> lượng</a:t>
-            </a:r>
-            <a:r>
-              <a:rPr lang="en-US" sz="2400" dirty="0" spc="1" kern="0">
-                <a:solidFill>
-                  <a:srgbClr val="3B3A37"/>
-                </a:solidFill>
-                <a:latin typeface="Be Vietnam Pro" pitchFamily="34" charset="0"/>
-                <a:ea typeface="Be Vietnam Pro" pitchFamily="34" charset="-122"/>
-                <a:cs typeface="Be Vietnam Pro" pitchFamily="34" charset="-120"/>
-              </a:rPr>
-              <a:t> phân</a:t>
-            </a:r>
-            <a:r>
-              <a:rPr lang="en-US" sz="2400" dirty="0" spc="-9" kern="0">
                 <a:solidFill>
                   <a:srgbClr val="3B3A37"/>
                 </a:solidFill>
@@ -14933,7 +14658,7 @@
               <a:t> bí</a:t>
             </a:r>
             <a:r>
-              <a:rPr lang="en-US" sz="2400" dirty="0" spc="-6" kern="0">
+              <a:rPr lang="en-US" sz="2400" dirty="0" spc="-7" kern="0">
                 <a:solidFill>
                   <a:srgbClr val="3B3A37"/>
                 </a:solidFill>
@@ -14941,8 +14666,17 @@
                 <a:ea typeface="Be Vietnam Pro" pitchFamily="34" charset="-122"/>
                 <a:cs typeface="Be Vietnam Pro" pitchFamily="34" charset="-120"/>
               </a:rPr>
-              <a:t> mật;</a:t>
-            </a:r>
+              <a:t> mật.</a:t>
+            </a:r>
+            <a:endParaRPr lang="en-US" sz="2400" dirty="0"/>
+          </a:p>
+          <a:p>
+            <a:pPr algn="l" indent="0" marL="0">
+              <a:lnSpc>
+                <a:spcPts val="3120"/>
+              </a:lnSpc>
+              <a:buNone/>
+            </a:pPr>
             <a:r>
               <a:rPr lang="en-US" sz="2400" dirty="0" spc="0" kern="0">
                 <a:solidFill>
@@ -14952,7 +14686,62 @@
                 <a:ea typeface="Be Vietnam Pro" pitchFamily="34" charset="-122"/>
                 <a:cs typeface="Be Vietnam Pro" pitchFamily="34" charset="-120"/>
               </a:rPr>
-              <a:t> giới</a:t>
+              <a:t>Giới</a:t>
+            </a:r>
+            <a:r>
+              <a:rPr lang="en-US" sz="2400" dirty="0" spc="1" kern="0">
+                <a:solidFill>
+                  <a:srgbClr val="3B3A37"/>
+                </a:solidFill>
+                <a:latin typeface="Be Vietnam Pro" pitchFamily="34" charset="0"/>
+                <a:ea typeface="Be Vietnam Pro" pitchFamily="34" charset="-122"/>
+                <a:cs typeface="Be Vietnam Pro" pitchFamily="34" charset="-120"/>
+              </a:rPr>
+              <a:t> hạn</a:t>
+            </a:r>
+            <a:r>
+              <a:rPr lang="en-US" sz="2400" dirty="0" spc="-14" kern="0">
+                <a:solidFill>
+                  <a:srgbClr val="3B3A37"/>
+                </a:solidFill>
+                <a:latin typeface="Be Vietnam Pro" pitchFamily="34" charset="0"/>
+                <a:ea typeface="Be Vietnam Pro" pitchFamily="34" charset="-122"/>
+                <a:cs typeface="Be Vietnam Pro" pitchFamily="34" charset="-120"/>
+              </a:rPr>
+              <a:t> quyền</a:t>
+            </a:r>
+            <a:r>
+              <a:rPr lang="en-US" sz="2400" dirty="0" spc="9" kern="0">
+                <a:solidFill>
+                  <a:srgbClr val="3B3A37"/>
+                </a:solidFill>
+                <a:latin typeface="Be Vietnam Pro" pitchFamily="34" charset="0"/>
+                <a:ea typeface="Be Vietnam Pro" pitchFamily="34" charset="-122"/>
+                <a:cs typeface="Be Vietnam Pro" pitchFamily="34" charset="-120"/>
+              </a:rPr>
+              <a:t> đọc</a:t>
+            </a:r>
+            <a:r>
+              <a:rPr lang="en-US" sz="2400" dirty="0" spc="-15" kern="0">
+                <a:solidFill>
+                  <a:srgbClr val="3B3A37"/>
+                </a:solidFill>
+                <a:latin typeface="Be Vietnam Pro" pitchFamily="34" charset="0"/>
+                <a:ea typeface="Be Vietnam Pro" pitchFamily="34" charset="-122"/>
+                <a:cs typeface="Be Vietnam Pro" pitchFamily="34" charset="-120"/>
+              </a:rPr>
+              <a:t> và</a:t>
+            </a:r>
+            <a:r>
+              <a:rPr lang="en-US" sz="2400" dirty="0" spc="0" kern="0">
+                <a:solidFill>
+                  <a:srgbClr val="3B3A37"/>
+                </a:solidFill>
+                <a:latin typeface="Be Vietnam Pro" pitchFamily="34" charset="0"/>
+                <a:ea typeface="Be Vietnam Pro" pitchFamily="34" charset="-122"/>
+                <a:cs typeface="Be Vietnam Pro" pitchFamily="34" charset="-120"/>
+              </a:rPr>
+              <a:t> thời</a:t>
             </a:r>
             <a:r>
               <a:rPr lang="en-US" sz="2400" dirty="0" spc="2" kern="0">
@@ -14963,10 +14752,10 @@
                 <a:ea typeface="Be Vietnam Pro" pitchFamily="34" charset="-122"/>
                 <a:cs typeface="Be Vietnam Pro" pitchFamily="34" charset="-120"/>
               </a:rPr>
-              <a:t> hạn</a:t>
-            </a:r>
-            <a:r>
-              <a:rPr lang="en-US" sz="2400" dirty="0" spc="-14" kern="0">
+              <a:t> gian</a:t>
+            </a:r>
+            <a:r>
+              <a:rPr lang="en-US" sz="2400" dirty="0" spc="12" kern="0">
                 <a:solidFill>
                   <a:srgbClr val="3B3A37"/>
                 </a:solidFill>
@@ -14974,62 +14763,7 @@
                 <a:ea typeface="Be Vietnam Pro" pitchFamily="34" charset="-122"/>
                 <a:cs typeface="Be Vietnam Pro" pitchFamily="34" charset="-120"/>
               </a:rPr>
-              <a:t> quyền</a:t>
-            </a:r>
-            <a:r>
-              <a:rPr lang="en-US" sz="2400" dirty="0" spc="9" kern="0">
-                <a:solidFill>
-                  <a:srgbClr val="3B3A37"/>
-                </a:solidFill>
-                <a:latin typeface="Be Vietnam Pro" pitchFamily="34" charset="0"/>
-                <a:ea typeface="Be Vietnam Pro" pitchFamily="34" charset="-122"/>
-                <a:cs typeface="Be Vietnam Pro" pitchFamily="34" charset="-120"/>
-              </a:rPr>
-              <a:t> đọc</a:t>
-            </a:r>
-            <a:r>
-              <a:rPr lang="en-US" sz="2400" dirty="0" spc="-15" kern="0">
-                <a:solidFill>
-                  <a:srgbClr val="3B3A37"/>
-                </a:solidFill>
-                <a:latin typeface="Be Vietnam Pro" pitchFamily="34" charset="0"/>
-                <a:ea typeface="Be Vietnam Pro" pitchFamily="34" charset="-122"/>
-                <a:cs typeface="Be Vietnam Pro" pitchFamily="34" charset="-120"/>
-              </a:rPr>
-              <a:t> và</a:t>
-            </a:r>
-            <a:r>
-              <a:rPr lang="en-US" sz="2400" dirty="0" spc="0" kern="0">
-                <a:solidFill>
-                  <a:srgbClr val="3B3A37"/>
-                </a:solidFill>
-                <a:latin typeface="Be Vietnam Pro" pitchFamily="34" charset="0"/>
-                <a:ea typeface="Be Vietnam Pro" pitchFamily="34" charset="-122"/>
-                <a:cs typeface="Be Vietnam Pro" pitchFamily="34" charset="-120"/>
-              </a:rPr>
-              <a:t> thời</a:t>
-            </a:r>
-            <a:r>
-              <a:rPr lang="en-US" sz="2400" dirty="0" spc="2" kern="0">
-                <a:solidFill>
-                  <a:srgbClr val="3B3A37"/>
-                </a:solidFill>
-                <a:latin typeface="Be Vietnam Pro" pitchFamily="34" charset="0"/>
-                <a:ea typeface="Be Vietnam Pro" pitchFamily="34" charset="-122"/>
-                <a:cs typeface="Be Vietnam Pro" pitchFamily="34" charset="-120"/>
-              </a:rPr>
-              <a:t> gian</a:t>
-            </a:r>
-            <a:r>
-              <a:rPr lang="en-US" sz="2400" dirty="0" spc="16" kern="0">
-                <a:solidFill>
-                  <a:srgbClr val="3B3A37"/>
-                </a:solidFill>
-                <a:latin typeface="Be Vietnam Pro" pitchFamily="34" charset="0"/>
-                <a:ea typeface="Be Vietnam Pro" pitchFamily="34" charset="-122"/>
-                <a:cs typeface="Be Vietnam Pro" pitchFamily="34" charset="-120"/>
-              </a:rPr>
-              <a:t> lưu</a:t>
+              <a:t> lưu.</a:t>
             </a:r>
             <a:endParaRPr lang="en-US" sz="2400" dirty="0"/>
           </a:p>
@@ -15130,7 +14864,7 @@
               <a:t> đe</a:t>
             </a:r>
             <a:r>
-              <a:rPr lang="en-US" sz="2100" dirty="0" spc="-6" kern="0">
+              <a:rPr lang="en-US" sz="2100" dirty="0" spc="-5" kern="0">
                 <a:solidFill>
                   <a:srgbClr val="F3EEE3"/>
                 </a:solidFill>
@@ -15138,21 +14872,10 @@
                 <a:ea typeface="Be Vietnam Pro SemiBold" pitchFamily="34" charset="-122"/>
                 <a:cs typeface="Be Vietnam Pro SemiBold" pitchFamily="34" charset="-120"/>
               </a:rPr>
-              <a:t> dọa</a:t>
-            </a:r>
-            <a:r>
-              <a:rPr lang="en-US" sz="2100" dirty="0" spc="-20" kern="0">
-                <a:solidFill>
-                  <a:srgbClr val="F3EEE3"/>
-                </a:solidFill>
-                <a:latin typeface="Be Vietnam Pro SemiBold" pitchFamily="34" charset="0"/>
-                <a:ea typeface="Be Vietnam Pro SemiBold" pitchFamily="34" charset="-122"/>
-                <a:cs typeface="Be Vietnam Pro SemiBold" pitchFamily="34" charset="-120"/>
-              </a:rPr>
-              <a:t> và</a:t>
-            </a:r>
-            <a:r>
-              <a:rPr lang="en-US" sz="2100" dirty="0" spc="-7" kern="0">
+              <a:t> dọa,</a:t>
+            </a:r>
+            <a:r>
+              <a:rPr lang="en-US" sz="2100" dirty="0" spc="-8" kern="0">
                 <a:solidFill>
                   <a:srgbClr val="F3EEE3"/>
                 </a:solidFill>

</xml_diff>

<commit_message>
Slides: question titles at 92 px on sd-01-030..034, re-export badged PPTX
Co-Authored-By: Claude Opus 5.5 <noreply@anthropic.com>
Claude-Session: https://claude.ai/code/session_01PmqNRWe4NoiAuhPfHYj9Qq
</commit_message>
<xml_diff>
--- a/system-design-101/vi/lessons/sd-01-030/slides/sd-01-030.pptx
+++ b/system-design-101/vi/lessons/sd-01-030/slides/sd-01-030.pptx
@@ -12641,8 +12641,8 @@
         </p:nvSpPr>
         <p:spPr>
           <a:xfrm>
-            <a:off x="1428750" y="4429125"/>
-            <a:ext cx="15430500" cy="952500"/>
+            <a:off x="1428750" y="4362450"/>
+            <a:ext cx="15430500" cy="1095375"/>
           </a:xfrm>
           <a:prstGeom prst="rect">
             <a:avLst/>
@@ -12651,17 +12651,17 @@
           <a:ln/>
         </p:spPr>
         <p:txBody>
-          <a:bodyPr wrap="square" lIns="0" tIns="36195" rIns="0" bIns="-36195" rtlCol="0" anchor="t"/>
+          <a:bodyPr wrap="square" lIns="0" tIns="43815" rIns="0" bIns="-43815" rtlCol="0" anchor="t"/>
           <a:lstStyle/>
           <a:p>
             <a:pPr algn="l" indent="0" marL="0">
               <a:lnSpc>
-                <a:spcPts val="6270"/>
+                <a:spcPts val="7590"/>
               </a:lnSpc>
               <a:buNone/>
             </a:pPr>
             <a:r>
-              <a:rPr lang="en-US" sz="5700" dirty="0" spc="2" kern="0">
+              <a:rPr lang="en-US" sz="6900" dirty="0" spc="4" kern="0">
                 <a:solidFill>
                   <a:srgbClr val="14161C"/>
                 </a:solidFill>
@@ -12669,10 +12669,10 @@
                 <a:ea typeface="Bricolage Grotesque ExtraBold" pitchFamily="34" charset="-122"/>
                 <a:cs typeface="Bricolage Grotesque ExtraBold" pitchFamily="34" charset="-120"/>
               </a:rPr>
-              <a:t>Kiểm</a:t>
-            </a:r>
-            <a:r>
-              <a:rPr lang="en-US" sz="5700" dirty="0" spc="1" kern="0">
+              <a:t>Kiểm quyền</a:t>
+            </a:r>
+            <a:r>
+              <a:rPr lang="en-US" sz="6900" dirty="0" spc="-13" kern="0">
                 <a:solidFill>
                   <a:srgbClr val="14161C"/>
                 </a:solidFill>
@@ -12680,10 +12680,10 @@
                 <a:ea typeface="Bricolage Grotesque ExtraBold" pitchFamily="34" charset="-122"/>
                 <a:cs typeface="Bricolage Grotesque ExtraBold" pitchFamily="34" charset="-120"/>
               </a:rPr>
-              <a:t> quyền</a:t>
-            </a:r>
-            <a:r>
-              <a:rPr lang="en-US" sz="5700" dirty="0" spc="-12" kern="0">
+              <a:t> trên</a:t>
+            </a:r>
+            <a:r>
+              <a:rPr lang="en-US" sz="6900" dirty="0" spc="12" kern="0">
                 <a:solidFill>
                   <a:srgbClr val="14161C"/>
                 </a:solidFill>
@@ -12691,10 +12691,10 @@
                 <a:ea typeface="Bricolage Grotesque ExtraBold" pitchFamily="34" charset="-122"/>
                 <a:cs typeface="Bricolage Grotesque ExtraBold" pitchFamily="34" charset="-120"/>
               </a:rPr>
-              <a:t> trên</a:t>
-            </a:r>
-            <a:r>
-              <a:rPr lang="en-US" sz="5700" dirty="0" spc="9" kern="0">
+              <a:t> đúng</a:t>
+            </a:r>
+            <a:r>
+              <a:rPr lang="en-US" sz="6900" dirty="0" spc="1" kern="0">
                 <a:solidFill>
                   <a:srgbClr val="14161C"/>
                 </a:solidFill>
@@ -12702,10 +12702,10 @@
                 <a:ea typeface="Bricolage Grotesque ExtraBold" pitchFamily="34" charset="-122"/>
                 <a:cs typeface="Bricolage Grotesque ExtraBold" pitchFamily="34" charset="-120"/>
               </a:rPr>
-              <a:t> đúng</a:t>
-            </a:r>
-            <a:r>
-              <a:rPr lang="en-US" sz="5700" dirty="0" spc="-2" kern="0">
+              <a:t> hồ</a:t>
+            </a:r>
+            <a:r>
+              <a:rPr lang="en-US" sz="6900" dirty="0" spc="-73" kern="0">
                 <a:solidFill>
                   <a:srgbClr val="14161C"/>
                 </a:solidFill>
@@ -12713,10 +12713,10 @@
                 <a:ea typeface="Bricolage Grotesque ExtraBold" pitchFamily="34" charset="-122"/>
                 <a:cs typeface="Bricolage Grotesque ExtraBold" pitchFamily="34" charset="-120"/>
               </a:rPr>
-              <a:t> hồ</a:t>
-            </a:r>
-            <a:r>
-              <a:rPr lang="en-US" sz="5700" dirty="0" spc="-62" kern="0">
+              <a:t> sơ,</a:t>
+            </a:r>
+            <a:r>
+              <a:rPr lang="en-US" sz="6900" dirty="0" spc="1" kern="0">
                 <a:solidFill>
                   <a:srgbClr val="14161C"/>
                 </a:solidFill>
@@ -12724,10 +12724,10 @@
                 <a:ea typeface="Bricolage Grotesque ExtraBold" pitchFamily="34" charset="-122"/>
                 <a:cs typeface="Bricolage Grotesque ExtraBold" pitchFamily="34" charset="-120"/>
               </a:rPr>
-              <a:t> sơ,</a:t>
-            </a:r>
-            <a:r>
-              <a:rPr lang="en-US" sz="5700" dirty="0" spc="-3" kern="0">
+              <a:t> ở</a:t>
+            </a:r>
+            <a:r>
+              <a:rPr lang="en-US" sz="6900" dirty="0" spc="-1" kern="0">
                 <a:solidFill>
                   <a:srgbClr val="14161C"/>
                 </a:solidFill>
@@ -12735,10 +12735,10 @@
                 <a:ea typeface="Bricolage Grotesque ExtraBold" pitchFamily="34" charset="-122"/>
                 <a:cs typeface="Bricolage Grotesque ExtraBold" pitchFamily="34" charset="-120"/>
               </a:rPr>
-              <a:t> ở</a:t>
-            </a:r>
-            <a:r>
-              <a:rPr lang="en-US" sz="5700" dirty="0" spc="-1" kern="0">
+              <a:t> máy</a:t>
+            </a:r>
+            <a:r>
+              <a:rPr lang="en-US" sz="6900" dirty="0" spc="0" kern="0">
                 <a:solidFill>
                   <a:srgbClr val="14161C"/>
                 </a:solidFill>
@@ -12746,9 +12746,9 @@
                 <a:ea typeface="Bricolage Grotesque ExtraBold" pitchFamily="34" charset="-122"/>
                 <a:cs typeface="Bricolage Grotesque ExtraBold" pitchFamily="34" charset="-120"/>
               </a:rPr>
-              <a:t> máy chủ</a:t>
-            </a:r>
-            <a:endParaRPr lang="en-US" sz="5700" dirty="0"/>
+              <a:t> chủ</a:t>
+            </a:r>
+            <a:endParaRPr lang="en-US" sz="6900" dirty="0"/>
           </a:p>
         </p:txBody>
       </p:sp>

</xml_diff>